<commit_message>
GP deck v2: judge-passed layout (full-width slides, team panel, no overlaps, 6-step journey, 113-deaths figure on slide 2)
</commit_message>
<xml_diff>
--- a/gp_submission/ShasthoSathi_GP_Deck.pptx
+++ b/gp_submission/ShasthoSathi_GP_Deck.pptx
@@ -1956,7 +1956,7 @@
                   <a:srgbClr val="134E4A"/>
                 </a:solidFill>
               </a:rPr>
-              <a:t>Team — [TEAM NAME]</a:t>
+              <a:t>Team — Team ShasthoSathi</a:t>
             </a:r>
             <a:endParaRPr lang="en-US" sz="3000" dirty="0"/>
           </a:p>
@@ -1971,7 +1971,7 @@
         <p:spPr>
           <a:xfrm>
             <a:off x="640080" y="1325880"/>
-            <a:ext cx="6766560" cy="4846320"/>
+            <a:ext cx="7863840" cy="4846320"/>
           </a:xfrm>
           <a:prstGeom prst="rect">
             <a:avLst/>
@@ -2014,7 +2014,7 @@
                   <a:srgbClr val="1E293B"/>
                 </a:solidFill>
               </a:rPr>
-              <a:t>Built &amp; shipped: MindWell (mental-health web app), RippleUp (Android+Desktop), SightlineAI, Team SignTalk — plus this project, already live</a:t>
+              <a:t>Built &amp; shipped: MindWell (mental-health web app), RippleUp (Android + Desktop), SightlineAI, Team SignTalk — plus this project, already live</a:t>
             </a:r>
             <a:endParaRPr lang="en-US" sz="1800" dirty="0"/>
           </a:p>
@@ -2050,7 +2050,7 @@
                   <a:srgbClr val="1E293B"/>
                 </a:solidFill>
               </a:rPr>
-              <a:t>Contact: [team email] · Solo team (eligible: 1–3 members)</a:t>
+              <a:t>Team of one (eligible: 1–3 members) · Contact: via the FutureMakers portal</a:t>
             </a:r>
             <a:endParaRPr lang="en-US" sz="1800" dirty="0"/>
           </a:p>
@@ -2058,13 +2058,207 @@
       </p:sp>
       <p:sp>
         <p:nvSpPr>
-          <p:cNvPr id="6" name="Text 4"/>
+          <p:cNvPr id="6" name="Shape 4"/>
           <p:cNvSpPr/>
           <p:nvPr/>
         </p:nvSpPr>
         <p:spPr>
           <a:xfrm>
-            <a:off x="640080" y="5394960"/>
+            <a:off x="8686800" y="1554480"/>
+            <a:ext cx="3017520" cy="4206240"/>
+          </a:xfrm>
+          <a:prstGeom prst="roundRect">
+            <a:avLst>
+              <a:gd name="adj" fmla="val 3636"/>
+            </a:avLst>
+          </a:prstGeom>
+          <a:solidFill>
+            <a:srgbClr val="134E4A"/>
+          </a:solidFill>
+          <a:ln/>
+        </p:spPr>
+      </p:sp>
+      <p:sp>
+        <p:nvSpPr>
+          <p:cNvPr id="7" name="Text 5"/>
+          <p:cNvSpPr/>
+          <p:nvPr/>
+        </p:nvSpPr>
+        <p:spPr>
+          <a:xfrm>
+            <a:off x="8686800" y="1828800"/>
+            <a:ext cx="3017520" cy="1097280"/>
+          </a:xfrm>
+          <a:prstGeom prst="rect">
+            <a:avLst/>
+          </a:prstGeom>
+          <a:noFill/>
+          <a:ln/>
+        </p:spPr>
+        <p:txBody>
+          <a:bodyPr wrap="square" rtlCol="0" anchor="ctr"/>
+          <a:lstStyle/>
+          <a:p>
+            <a:pPr algn="ctr" indent="0" marL="0">
+              <a:buNone/>
+            </a:pPr>
+            <a:r>
+              <a:rPr lang="en-US" sz="6000" b="1" dirty="0">
+                <a:solidFill>
+                  <a:srgbClr val="FFFFFF"/>
+                </a:solidFill>
+              </a:rPr>
+              <a:t>✚</a:t>
+            </a:r>
+            <a:endParaRPr lang="en-US" sz="6000" dirty="0"/>
+          </a:p>
+        </p:txBody>
+      </p:sp>
+      <p:sp>
+        <p:nvSpPr>
+          <p:cNvPr id="8" name="Text 6"/>
+          <p:cNvSpPr/>
+          <p:nvPr/>
+        </p:nvSpPr>
+        <p:spPr>
+          <a:xfrm>
+            <a:off x="8686800" y="2926080"/>
+            <a:ext cx="3017520" cy="457200"/>
+          </a:xfrm>
+          <a:prstGeom prst="rect">
+            <a:avLst/>
+          </a:prstGeom>
+          <a:noFill/>
+          <a:ln/>
+        </p:spPr>
+        <p:txBody>
+          <a:bodyPr wrap="square" rtlCol="0" anchor="ctr"/>
+          <a:lstStyle/>
+          <a:p>
+            <a:pPr algn="ctr" indent="0" marL="0">
+              <a:buNone/>
+            </a:pPr>
+            <a:r>
+              <a:rPr lang="en-US" sz="2000" b="1" dirty="0">
+                <a:solidFill>
+                  <a:srgbClr val="FFFFFF"/>
+                </a:solidFill>
+              </a:rPr>
+              <a:t>ShasthoSathi</a:t>
+            </a:r>
+            <a:endParaRPr lang="en-US" sz="2000" dirty="0"/>
+          </a:p>
+        </p:txBody>
+      </p:sp>
+      <p:sp>
+        <p:nvSpPr>
+          <p:cNvPr id="9" name="Text 7"/>
+          <p:cNvSpPr/>
+          <p:nvPr/>
+        </p:nvSpPr>
+        <p:spPr>
+          <a:xfrm>
+            <a:off x="8686800" y="3383280"/>
+            <a:ext cx="3017520" cy="457200"/>
+          </a:xfrm>
+          <a:prstGeom prst="rect">
+            <a:avLst/>
+          </a:prstGeom>
+          <a:noFill/>
+          <a:ln/>
+        </p:spPr>
+        <p:txBody>
+          <a:bodyPr wrap="square" rtlCol="0" anchor="ctr"/>
+          <a:lstStyle/>
+          <a:p>
+            <a:pPr algn="ctr" indent="0" marL="0">
+              <a:buNone/>
+            </a:pPr>
+            <a:r>
+              <a:rPr lang="en-US" sz="1800" dirty="0">
+                <a:solidFill>
+                  <a:srgbClr val="A7F3D0"/>
+                </a:solidFill>
+              </a:rPr>
+              <a:t>স্বাস্থ্যসাথী</a:t>
+            </a:r>
+            <a:endParaRPr lang="en-US" sz="1800" dirty="0"/>
+          </a:p>
+        </p:txBody>
+      </p:sp>
+      <p:sp>
+        <p:nvSpPr>
+          <p:cNvPr id="10" name="Text 8"/>
+          <p:cNvSpPr/>
+          <p:nvPr/>
+        </p:nvSpPr>
+        <p:spPr>
+          <a:xfrm>
+            <a:off x="8778240" y="4023360"/>
+            <a:ext cx="2834640" cy="1463040"/>
+          </a:xfrm>
+          <a:prstGeom prst="rect">
+            <a:avLst/>
+          </a:prstGeom>
+          <a:noFill/>
+          <a:ln/>
+        </p:spPr>
+        <p:txBody>
+          <a:bodyPr wrap="square" rtlCol="0" anchor="ctr"/>
+          <a:lstStyle/>
+          <a:p>
+            <a:pPr algn="ctr" indent="0" marL="0">
+              <a:buNone/>
+            </a:pPr>
+            <a:r>
+              <a:rPr lang="en-US" sz="1400" dirty="0">
+                <a:solidFill>
+                  <a:srgbClr val="FFFFFF"/>
+                </a:solidFill>
+              </a:rPr>
+              <a:t>LIVE →</a:t>
+            </a:r>
+            <a:endParaRPr lang="en-US" sz="1400" dirty="0"/>
+          </a:p>
+          <a:p>
+            <a:pPr algn="ctr" indent="0" marL="0">
+              <a:buNone/>
+            </a:pPr>
+            <a:r>
+              <a:rPr lang="en-US" sz="1400" dirty="0">
+                <a:solidFill>
+                  <a:srgbClr val="FFFFFF"/>
+                </a:solidFill>
+              </a:rPr>
+              <a:t>rudra496.github.io</a:t>
+            </a:r>
+            <a:endParaRPr lang="en-US" sz="1400" dirty="0"/>
+          </a:p>
+          <a:p>
+            <a:pPr algn="ctr" indent="0" marL="0">
+              <a:buNone/>
+            </a:pPr>
+            <a:r>
+              <a:rPr lang="en-US" sz="1400" dirty="0">
+                <a:solidFill>
+                  <a:srgbClr val="FFFFFF"/>
+                </a:solidFill>
+              </a:rPr>
+              <a:t>/shasthosathi</a:t>
+            </a:r>
+            <a:endParaRPr lang="en-US" sz="1400" dirty="0"/>
+          </a:p>
+        </p:txBody>
+      </p:sp>
+      <p:sp>
+        <p:nvSpPr>
+          <p:cNvPr id="11" name="Text 9"/>
+          <p:cNvSpPr/>
+          <p:nvPr/>
+        </p:nvSpPr>
+        <p:spPr>
+          <a:xfrm>
+            <a:off x="640080" y="5806440"/>
             <a:ext cx="10881360" cy="548640"/>
           </a:xfrm>
           <a:prstGeom prst="rect">
@@ -2241,7 +2435,7 @@
         <p:spPr>
           <a:xfrm>
             <a:off x="640080" y="1325880"/>
-            <a:ext cx="6766560" cy="4846320"/>
+            <a:ext cx="10881360" cy="4846320"/>
           </a:xfrm>
           <a:prstGeom prst="rect">
             <a:avLst/>
@@ -2493,7 +2687,7 @@
         <p:spPr>
           <a:xfrm>
             <a:off x="640080" y="1325880"/>
-            <a:ext cx="6766560" cy="4846320"/>
+            <a:ext cx="10881360" cy="4846320"/>
           </a:xfrm>
           <a:prstGeom prst="rect">
             <a:avLst/>
@@ -2745,7 +2939,7 @@
         <p:spPr>
           <a:xfrm>
             <a:off x="640080" y="1325880"/>
-            <a:ext cx="6766560" cy="4846320"/>
+            <a:ext cx="10881360" cy="4846320"/>
           </a:xfrm>
           <a:prstGeom prst="rect">
             <a:avLst/>
@@ -3243,7 +3437,7 @@
                   <a:srgbClr val="B45309"/>
                 </a:solidFill>
               </a:rPr>
-              <a:t>41,032</a:t>
+              <a:t>41,032 / 113</a:t>
             </a:r>
             <a:endParaRPr lang="en-US" sz="3000" dirty="0"/>
           </a:p>
@@ -3279,7 +3473,7 @@
                   <a:srgbClr val="475569"/>
                 </a:solidFill>
               </a:rPr>
-              <a:t>cases already in 2026 (to 5 Sep, DGHS)</a:t>
+              <a:t>2026 cases/deaths to 5 Sep (DGHS)</a:t>
             </a:r>
             <a:endParaRPr lang="en-US" sz="1200" dirty="0"/>
           </a:p>
@@ -3392,8 +3586,8 @@
         </p:nvSpPr>
         <p:spPr>
           <a:xfrm>
-            <a:off x="640080" y="1325880"/>
-            <a:ext cx="6766560" cy="4846320"/>
+            <a:off x="640080" y="3474720"/>
+            <a:ext cx="10881360" cy="2743200"/>
           </a:xfrm>
           <a:prstGeom prst="rect">
             <a:avLst/>
@@ -3413,14 +3607,14 @@
               <a:buChar char="•"/>
             </a:pPr>
             <a:r>
-              <a:rPr lang="en-US" sz="1700" dirty="0">
+              <a:rPr lang="en-US" sz="1600" dirty="0">
                 <a:solidFill>
                   <a:srgbClr val="1E293B"/>
                 </a:solidFill>
               </a:rPr>
               <a:t>Community health workers (CHWs) meet every patient first — with paper, memory, and no AI support</a:t>
             </a:r>
-            <a:endParaRPr lang="en-US" sz="1700" dirty="0"/>
+            <a:endParaRPr lang="en-US" sz="1600" dirty="0"/>
           </a:p>
           <a:p>
             <a:pPr marL="342900" indent="-342900">
@@ -3431,14 +3625,14 @@
               <a:buChar char="•"/>
             </a:pPr>
             <a:r>
-              <a:rPr lang="en-US" sz="1700" dirty="0">
+              <a:rPr lang="en-US" sz="1600" dirty="0">
                 <a:solidFill>
                   <a:srgbClr val="1E293B"/>
                 </a:solidFill>
               </a:rPr>
               <a:t>Internet is unreliable where they work → any cloud-only app fails exactly when needed</a:t>
             </a:r>
-            <a:endParaRPr lang="en-US" sz="1700" dirty="0"/>
+            <a:endParaRPr lang="en-US" sz="1600" dirty="0"/>
           </a:p>
           <a:p>
             <a:pPr marL="342900" indent="-342900">
@@ -3449,14 +3643,14 @@
               <a:buChar char="•"/>
             </a:pPr>
             <a:r>
-              <a:rPr lang="en-US" sz="1700" dirty="0">
+              <a:rPr lang="en-US" sz="1600" dirty="0">
                 <a:solidFill>
                   <a:srgbClr val="1E293B"/>
                 </a:solidFill>
               </a:rPr>
               <a:t>Outbreak detection lags weeks; resources (test kits, volunteers, beds) are allocated without current division-level evidence</a:t>
             </a:r>
-            <a:endParaRPr lang="en-US" sz="1700" dirty="0"/>
+            <a:endParaRPr lang="en-US" sz="1600" dirty="0"/>
           </a:p>
           <a:p>
             <a:pPr marL="342900" indent="-342900">
@@ -3467,14 +3661,14 @@
               <a:buChar char="•"/>
             </a:pPr>
             <a:r>
-              <a:rPr lang="en-US" sz="1700" dirty="0">
+              <a:rPr lang="en-US" sz="1600" dirty="0">
                 <a:solidFill>
                   <a:srgbClr val="1E293B"/>
                 </a:solidFill>
               </a:rPr>
               <a:t>Feature-phone and low-literacy users are excluded by app-first solutions</a:t>
             </a:r>
-            <a:endParaRPr lang="en-US" sz="1700" dirty="0"/>
+            <a:endParaRPr lang="en-US" sz="1600" dirty="0"/>
           </a:p>
         </p:txBody>
       </p:sp>
@@ -3627,7 +3821,7 @@
         <p:spPr>
           <a:xfrm>
             <a:off x="640080" y="1325880"/>
-            <a:ext cx="6766560" cy="4846320"/>
+            <a:ext cx="10881360" cy="4846320"/>
           </a:xfrm>
           <a:prstGeom prst="rect">
             <a:avLst/>
@@ -3647,14 +3841,14 @@
               <a:buChar char="•"/>
             </a:pPr>
             <a:r>
-              <a:rPr lang="en-US" sz="1900" dirty="0">
+              <a:rPr lang="en-US" sz="2000" dirty="0">
                 <a:solidFill>
                   <a:srgbClr val="1E293B"/>
                 </a:solidFill>
               </a:rPr>
               <a:t>PRIMARY USERS — community health workers &amp; supervisors in dengue-endemic wards (urban + rural)</a:t>
             </a:r>
-            <a:endParaRPr lang="en-US" sz="1900" dirty="0"/>
+            <a:endParaRPr lang="en-US" sz="2000" dirty="0"/>
           </a:p>
           <a:p>
             <a:pPr marL="342900" indent="-342900">
@@ -3665,14 +3859,14 @@
               <a:buChar char="•"/>
             </a:pPr>
             <a:r>
-              <a:rPr lang="en-US" sz="1900" dirty="0">
+              <a:rPr lang="en-US" sz="2000" dirty="0">
                 <a:solidFill>
                   <a:srgbClr val="1E293B"/>
                 </a:solidFill>
               </a:rPr>
               <a:t>PRIMARY BENEFICIARIES — low-income families at first contact: low-literacy users, feature-phone users (SMS mode), elderly patients</a:t>
             </a:r>
-            <a:endParaRPr lang="en-US" sz="1900" dirty="0"/>
+            <a:endParaRPr lang="en-US" sz="2000" dirty="0"/>
           </a:p>
           <a:p>
             <a:pPr marL="342900" indent="-342900">
@@ -3683,14 +3877,14 @@
               <a:buChar char="•"/>
             </a:pPr>
             <a:r>
-              <a:rPr lang="en-US" sz="1900" dirty="0">
+              <a:rPr lang="en-US" sz="2000" dirty="0">
                 <a:solidFill>
                   <a:srgbClr val="1E293B"/>
                 </a:solidFill>
               </a:rPr>
               <a:t>INSTITUTIONAL — city corporations, DGHS/IEDCR programme officers, NGOs needing early-warning + prioritization views</a:t>
             </a:r>
-            <a:endParaRPr lang="en-US" sz="1900" dirty="0"/>
+            <a:endParaRPr lang="en-US" sz="2000" dirty="0"/>
           </a:p>
           <a:p>
             <a:pPr marL="342900" indent="-342900">
@@ -3701,14 +3895,14 @@
               <a:buChar char="•"/>
             </a:pPr>
             <a:r>
-              <a:rPr lang="en-US" sz="1900" dirty="0">
+              <a:rPr lang="en-US" sz="2000" dirty="0">
                 <a:solidFill>
                   <a:srgbClr val="1E293B"/>
                 </a:solidFill>
               </a:rPr>
               <a:t>Designed WITH the constraint, not against it: voice-first Bangla UX, offline-first architecture, no smartphone required for SMS mode</a:t>
             </a:r>
-            <a:endParaRPr lang="en-US" sz="1900" dirty="0"/>
+            <a:endParaRPr lang="en-US" sz="2000" dirty="0"/>
           </a:p>
         </p:txBody>
       </p:sp>
@@ -3861,7 +4055,7 @@
         <p:spPr>
           <a:xfrm>
             <a:off x="640080" y="1325880"/>
-            <a:ext cx="6766560" cy="4846320"/>
+            <a:ext cx="10881360" cy="4846320"/>
           </a:xfrm>
           <a:prstGeom prst="rect">
             <a:avLst/>
@@ -3881,14 +4075,14 @@
               <a:buChar char="•"/>
             </a:pPr>
             <a:r>
-              <a:rPr lang="en-US" sz="1700" dirty="0">
+              <a:rPr lang="en-US" sz="1800" dirty="0">
                 <a:solidFill>
                   <a:srgbClr val="1E293B"/>
                 </a:solidFill>
               </a:rPr>
               <a:t>Peer-reviewed foundation: 64 Crossref-verified papers — Q1 spotlight incl. The Lancet Global Health (2024 dengue vaccine trial), Nature Medicine, PLOS NTD, IJID</a:t>
             </a:r>
-            <a:endParaRPr lang="en-US" sz="1700" dirty="0"/>
+            <a:endParaRPr lang="en-US" sz="1800" dirty="0"/>
           </a:p>
           <a:p>
             <a:pPr marL="342900" indent="-342900">
@@ -3899,14 +4093,14 @@
               <a:buChar char="•"/>
             </a:pPr>
             <a:r>
-              <a:rPr lang="en-US" sz="1700" dirty="0">
+              <a:rPr lang="en-US" sz="1800" dirty="0">
                 <a:solidFill>
                   <a:srgbClr val="1E293B"/>
                 </a:solidFill>
               </a:rPr>
               <a:t>Clinical core: WHO 2009 dengue classification (warning signs validated — Hadinegoro 2012)</a:t>
             </a:r>
-            <a:endParaRPr lang="en-US" sz="1700" dirty="0"/>
+            <a:endParaRPr lang="en-US" sz="1800" dirty="0"/>
           </a:p>
           <a:p>
             <a:pPr marL="342900" indent="-342900">
@@ -3917,14 +4111,14 @@
               <a:buChar char="•"/>
             </a:pPr>
             <a:r>
-              <a:rPr lang="en-US" sz="1700" dirty="0">
+              <a:rPr lang="en-US" sz="1800" dirty="0">
                 <a:solidFill>
                   <a:srgbClr val="1E293B"/>
                 </a:solidFill>
               </a:rPr>
               <a:t>Data spine: DGHS dashboard (2023→2026 YTD, division-level), WHO, IEDCR, BBS Census 2022, Open-Meteo weather — every number traceable, zero synthetic data</a:t>
             </a:r>
-            <a:endParaRPr lang="en-US" sz="1700" dirty="0"/>
+            <a:endParaRPr lang="en-US" sz="1800" dirty="0"/>
           </a:p>
           <a:p>
             <a:pPr marL="342900" indent="-342900">
@@ -3935,14 +4129,14 @@
               <a:buChar char="•"/>
             </a:pPr>
             <a:r>
-              <a:rPr lang="en-US" sz="1700" dirty="0">
+              <a:rPr lang="en-US" sz="1800" dirty="0">
                 <a:solidFill>
                   <a:srgbClr val="1E293B"/>
                 </a:solidFill>
               </a:rPr>
               <a:t>Model honesty, in public: R²(log)=0.93 on 2023; live 2026 check shows shape captured (Aug = actual peak), amplitude gap ~2.8× disclosed in-app + Model Card</a:t>
             </a:r>
-            <a:endParaRPr lang="en-US" sz="1700" dirty="0"/>
+            <a:endParaRPr lang="en-US" sz="1800" dirty="0"/>
           </a:p>
           <a:p>
             <a:pPr marL="342900" indent="-342900">
@@ -3953,14 +4147,14 @@
               <a:buChar char="•"/>
             </a:pPr>
             <a:r>
-              <a:rPr lang="en-US" sz="1700" dirty="0">
+              <a:rPr lang="en-US" sz="1800" dirty="0">
                 <a:solidFill>
                   <a:srgbClr val="1E293B"/>
                 </a:solidFill>
               </a:rPr>
               <a:t>Automated data-integrity tests: build FAILS if any dataset stops matching its published totals</a:t>
             </a:r>
-            <a:endParaRPr lang="en-US" sz="1700" dirty="0"/>
+            <a:endParaRPr lang="en-US" sz="1800" dirty="0"/>
           </a:p>
         </p:txBody>
       </p:sp>
@@ -4113,7 +4307,7 @@
         <p:spPr>
           <a:xfrm>
             <a:off x="640080" y="1325880"/>
-            <a:ext cx="6766560" cy="4846320"/>
+            <a:ext cx="10881360" cy="4846320"/>
           </a:xfrm>
           <a:prstGeom prst="rect">
             <a:avLst/>
@@ -5682,7 +5876,7 @@
         <p:spPr>
           <a:xfrm>
             <a:off x="640080" y="1325880"/>
-            <a:ext cx="6766560" cy="4846320"/>
+            <a:ext cx="10881360" cy="4846320"/>
           </a:xfrm>
           <a:prstGeom prst="rect">
             <a:avLst/>
@@ -5702,14 +5896,14 @@
               <a:buChar char="•"/>
             </a:pPr>
             <a:r>
-              <a:rPr lang="en-US" sz="1700" dirty="0">
+              <a:rPr lang="en-US" sz="1800" dirty="0">
                 <a:solidFill>
                   <a:srgbClr val="1E293B"/>
                 </a:solidFill>
               </a:rPr>
               <a:t>1️⃣ Open ShasthoSathi (home screen — works offline)  →  2️⃣ Speak symptoms in Bangla</a:t>
             </a:r>
-            <a:endParaRPr lang="en-US" sz="1700" dirty="0"/>
+            <a:endParaRPr lang="en-US" sz="1800" dirty="0"/>
           </a:p>
           <a:p>
             <a:pPr marL="342900" indent="-342900">
@@ -5720,14 +5914,14 @@
               <a:buChar char="•"/>
             </a:pPr>
             <a:r>
-              <a:rPr lang="en-US" sz="1700" dirty="0">
+              <a:rPr lang="en-US" sz="1800" dirty="0">
                 <a:solidFill>
                   <a:srgbClr val="1E293B"/>
                 </a:solidFill>
               </a:rPr>
               <a:t>3️⃣ Engine answers: “hospital TODAY” + shows which WHO warning signs triggered</a:t>
             </a:r>
-            <a:endParaRPr lang="en-US" sz="1700" dirty="0"/>
+            <a:endParaRPr lang="en-US" sz="1800" dirty="0"/>
           </a:p>
           <a:p>
             <a:pPr marL="342900" indent="-342900">
@@ -5738,14 +5932,14 @@
               <a:buChar char="•"/>
             </a:pPr>
             <a:r>
-              <a:rPr lang="en-US" sz="1700" dirty="0">
+              <a:rPr lang="en-US" sz="1800" dirty="0">
                 <a:solidFill>
                   <a:srgbClr val="1E293B"/>
                 </a:solidFill>
               </a:rPr>
               <a:t>4️⃣ One-tap call 999/16263 · follow-up auto-created for tomorrow · case saved on-device</a:t>
             </a:r>
-            <a:endParaRPr lang="en-US" sz="1700" dirty="0"/>
+            <a:endParaRPr lang="en-US" sz="1800" dirty="0"/>
           </a:p>
           <a:p>
             <a:pPr marL="342900" indent="-342900">
@@ -5756,14 +5950,14 @@
               <a:buChar char="•"/>
             </a:pPr>
             <a:r>
-              <a:rPr lang="en-US" sz="1700" dirty="0">
+              <a:rPr lang="en-US" sz="1800" dirty="0">
                 <a:solidFill>
                   <a:srgbClr val="1E293B"/>
                 </a:solidFill>
               </a:rPr>
               <a:t>5️⃣ Supervisor dashboard: new ward cases appear in the division map → bulletin drafted → kits/volunteers prioritized</a:t>
             </a:r>
-            <a:endParaRPr lang="en-US" sz="1700" dirty="0"/>
+            <a:endParaRPr lang="en-US" sz="1800" dirty="0"/>
           </a:p>
           <a:p>
             <a:pPr marL="342900" indent="-342900">
@@ -5774,14 +5968,14 @@
               <a:buChar char="•"/>
             </a:pPr>
             <a:r>
-              <a:rPr lang="en-US" sz="1700" dirty="0">
+              <a:rPr lang="en-US" sz="1800" dirty="0">
                 <a:solidFill>
                   <a:srgbClr val="1E293B"/>
                 </a:solidFill>
               </a:rPr>
-              <a:t>Feature-phone path: SMS “DENGUE FEVER PAIN” → same reply logic (simulated in-app; gateway-ready)</a:t>
-            </a:r>
-            <a:endParaRPr lang="en-US" sz="1700" dirty="0"/>
+              <a:t>6️⃣ Feature-phone path: SMS “DENGUE FEVER PAIN” → same reply logic (simulated in-app; gateway-ready)</a:t>
+            </a:r>
+            <a:endParaRPr lang="en-US" sz="1800" dirty="0"/>
           </a:p>
         </p:txBody>
       </p:sp>
@@ -5934,7 +6128,7 @@
         <p:spPr>
           <a:xfrm>
             <a:off x="640080" y="1325880"/>
-            <a:ext cx="6766560" cy="4846320"/>
+            <a:ext cx="10881360" cy="4846320"/>
           </a:xfrm>
           <a:prstGeom prst="rect">
             <a:avLst/>
@@ -5954,14 +6148,14 @@
               <a:buChar char="•"/>
             </a:pPr>
             <a:r>
-              <a:rPr lang="en-US" sz="1700" dirty="0">
+              <a:rPr lang="en-US" sz="1800" dirty="0">
                 <a:solidFill>
                   <a:srgbClr val="1E293B"/>
                 </a:solidFill>
               </a:rPr>
               <a:t>Clinical: decisions in the critical window (fever days 3–7, WHO) become consistent, explained, and escalation-biased — fewer missed warning signs</a:t>
             </a:r>
-            <a:endParaRPr lang="en-US" sz="1700" dirty="0"/>
+            <a:endParaRPr lang="en-US" sz="1800" dirty="0"/>
           </a:p>
           <a:p>
             <a:pPr marL="342900" indent="-342900">
@@ -5972,14 +6166,14 @@
               <a:buChar char="•"/>
             </a:pPr>
             <a:r>
-              <a:rPr lang="en-US" sz="1700" dirty="0">
+              <a:rPr lang="en-US" sz="1800" dirty="0">
                 <a:solidFill>
                   <a:srgbClr val="1E293B"/>
                 </a:solidFill>
               </a:rPr>
               <a:t>Inclusion: voice-first Bangla + SMS reaches users that app-first tools exclude — measured by design, not by retrofit</a:t>
             </a:r>
-            <a:endParaRPr lang="en-US" sz="1700" dirty="0"/>
+            <a:endParaRPr lang="en-US" sz="1800" dirty="0"/>
           </a:p>
           <a:p>
             <a:pPr marL="342900" indent="-342900">
@@ -5990,14 +6184,14 @@
               <a:buChar char="•"/>
             </a:pPr>
             <a:r>
-              <a:rPr lang="en-US" sz="1700" dirty="0">
+              <a:rPr lang="en-US" sz="1800" dirty="0">
                 <a:solidFill>
                   <a:srgbClr val="1E293B"/>
                 </a:solidFill>
               </a:rPr>
               <a:t>System: supervisors allocate from CURRENT division data (2026 live) instead of weeks-old reports</a:t>
             </a:r>
-            <a:endParaRPr lang="en-US" sz="1700" dirty="0"/>
+            <a:endParaRPr lang="en-US" sz="1800" dirty="0"/>
           </a:p>
           <a:p>
             <a:pPr marL="342900" indent="-342900">
@@ -6008,14 +6202,14 @@
               <a:buChar char="•"/>
             </a:pPr>
             <a:r>
-              <a:rPr lang="en-US" sz="1700" dirty="0">
+              <a:rPr lang="en-US" sz="1800" dirty="0">
                 <a:solidFill>
                   <a:srgbClr val="1E293B"/>
                 </a:solidFill>
               </a:rPr>
               <a:t>Scalable public good: clinical content + language packs are data files — any dengue-endemic country adopts with two JSON edits</a:t>
             </a:r>
-            <a:endParaRPr lang="en-US" sz="1700" dirty="0"/>
+            <a:endParaRPr lang="en-US" sz="1800" dirty="0"/>
           </a:p>
           <a:p>
             <a:pPr marL="342900" indent="-342900">
@@ -6026,14 +6220,14 @@
               <a:buChar char="•"/>
             </a:pPr>
             <a:r>
-              <a:rPr lang="en-US" sz="1700" dirty="0">
+              <a:rPr lang="en-US" sz="1800" dirty="0">
                 <a:solidFill>
                   <a:srgbClr val="1E293B"/>
                 </a:solidFill>
               </a:rPr>
               <a:t>Measurable pilot metrics: triage-to-referral time, warning-sign capture rate, follow-up compliance %, dashboard adoption by supervisors</a:t>
             </a:r>
-            <a:endParaRPr lang="en-US" sz="1700" dirty="0"/>
+            <a:endParaRPr lang="en-US" sz="1800" dirty="0"/>
           </a:p>
         </p:txBody>
       </p:sp>
@@ -6186,7 +6380,7 @@
         <p:spPr>
           <a:xfrm>
             <a:off x="640080" y="1325880"/>
-            <a:ext cx="6766560" cy="4846320"/>
+            <a:ext cx="10881360" cy="4846320"/>
           </a:xfrm>
           <a:prstGeom prst="rect">
             <a:avLst/>

</xml_diff>

<commit_message>
v1.3.1 hardening: XSS escaping on user-rendered fields, aria labels, judge 60-second test card on home; GP submission v2 (disclosure per FAQ, GP-partnership section, impact model est.); deck v3 (QR slide 1, GP block slide 12); video v3 (QR end-card, 1:47/2.27MB)
</commit_message>
<xml_diff>
--- a/gp_submission/ShasthoSathi_GP_Deck.pptx
+++ b/gp_submission/ShasthoSathi_GP_Deck.pptx
@@ -2186,16 +2186,40 @@
           </a:p>
         </p:txBody>
       </p:sp>
-      <p:sp>
-        <p:nvSpPr>
-          <p:cNvPr id="10" name="Text 8"/>
+      <p:pic>
+        <p:nvPicPr>
+          <p:cNvPr id="10" name="Image 0" descr="qr-demo.png">    </p:cNvPr>
+          <p:cNvPicPr>
+            <a:picLocks noChangeAspect="1"/>
+          </p:cNvPicPr>
+          <p:nvPr/>
+        </p:nvPicPr>
+        <p:blipFill>
+          <a:blip r:embed="rId1"/>
+          <a:stretch>
+            <a:fillRect/>
+          </a:stretch>
+        </p:blipFill>
+        <p:spPr>
+          <a:xfrm>
+            <a:off x="9052560" y="3931920"/>
+            <a:ext cx="2286000" cy="2286000"/>
+          </a:xfrm>
+          <a:prstGeom prst="rect">
+            <a:avLst/>
+          </a:prstGeom>
+        </p:spPr>
+      </p:pic>
+      <p:sp>
+        <p:nvSpPr>
+          <p:cNvPr id="11" name="Text 8"/>
           <p:cNvSpPr/>
           <p:nvPr/>
         </p:nvSpPr>
         <p:spPr>
           <a:xfrm>
-            <a:off x="8778240" y="4023360"/>
-            <a:ext cx="2834640" cy="1463040"/>
+            <a:off x="8686800" y="6263640"/>
+            <a:ext cx="3017520" cy="320040"/>
           </a:xfrm>
           <a:prstGeom prst="rect">
             <a:avLst/>
@@ -2211,48 +2235,20 @@
               <a:buNone/>
             </a:pPr>
             <a:r>
-              <a:rPr lang="en-US" sz="1400" dirty="0">
-                <a:solidFill>
-                  <a:srgbClr val="FFFFFF"/>
-                </a:solidFill>
-              </a:rPr>
-              <a:t>LIVE →</a:t>
-            </a:r>
-            <a:endParaRPr lang="en-US" sz="1400" dirty="0"/>
-          </a:p>
-          <a:p>
-            <a:pPr algn="ctr" indent="0" marL="0">
-              <a:buNone/>
-            </a:pPr>
-            <a:r>
-              <a:rPr lang="en-US" sz="1400" dirty="0">
-                <a:solidFill>
-                  <a:srgbClr val="FFFFFF"/>
-                </a:solidFill>
-              </a:rPr>
-              <a:t>rudra496.github.io</a:t>
-            </a:r>
-            <a:endParaRPr lang="en-US" sz="1400" dirty="0"/>
-          </a:p>
-          <a:p>
-            <a:pPr algn="ctr" indent="0" marL="0">
-              <a:buNone/>
-            </a:pPr>
-            <a:r>
-              <a:rPr lang="en-US" sz="1400" dirty="0">
-                <a:solidFill>
-                  <a:srgbClr val="FFFFFF"/>
-                </a:solidFill>
-              </a:rPr>
-              <a:t>/shasthosathi</a:t>
-            </a:r>
-            <a:endParaRPr lang="en-US" sz="1400" dirty="0"/>
-          </a:p>
-        </p:txBody>
-      </p:sp>
-      <p:sp>
-        <p:nvSpPr>
-          <p:cNvPr id="11" name="Text 9"/>
+              <a:rPr lang="en-US" sz="1100" dirty="0">
+                <a:solidFill>
+                  <a:srgbClr val="A7F3D0"/>
+                </a:solidFill>
+              </a:rPr>
+              <a:t>scan → open → airplane-mode test</a:t>
+            </a:r>
+            <a:endParaRPr lang="en-US" sz="1100" dirty="0"/>
+          </a:p>
+        </p:txBody>
+      </p:sp>
+      <p:sp>
+        <p:nvSpPr>
+          <p:cNvPr id="12" name="Text 9"/>
           <p:cNvSpPr/>
           <p:nvPr/>
         </p:nvSpPr>
@@ -3001,6 +2997,24 @@
                 </a:solidFill>
               </a:rPr>
               <a:t>Roadmap: on-device Gemma-class LLM for richer consultation summaries (RAM-permitting) · ward-level case-feedback model · vaccine/ANC SMS automation via gateway</a:t>
+            </a:r>
+            <a:endParaRPr lang="en-US" sz="1650" dirty="0"/>
+          </a:p>
+          <a:p>
+            <a:pPr marL="342900" indent="-342900">
+              <a:lnSpc>
+                <a:spcPct val="125000"/>
+              </a:lnSpc>
+              <a:buSzPct val="100000"/>
+              <a:buChar char="•"/>
+            </a:pPr>
+            <a:r>
+              <a:rPr lang="en-US" sz="1650" dirty="0">
+                <a:solidFill>
+                  <a:srgbClr val="1E293B"/>
+                </a:solidFill>
+              </a:rPr>
+              <a:t>Built for GP's assets: SMS gateway (simulated in-product) → live for every feature-phone user · zero-rating health traffic → free for all GP customers · MyGP integration · GP-brokered DGHS data partnership closes the forecast gap</a:t>
             </a:r>
             <a:endParaRPr lang="en-US" sz="1650" dirty="0"/>
           </a:p>

</xml_diff>

<commit_message>
v1.4.0: TRAINED on-device NLP — multinomial NB symptom classifier (multi-label corpus incl. multi-symptom sentences, positive-evidence scoring + freq gate, NegEx negation suppression): held-out micro-F1 0.969, negation rejection 91%, 94.5 KB, pure-JS offline inference; AI-Inside page (live demo + metrics + why-not-ChatGPT); wired into triage voice path; 67/67 tests
</commit_message>
<xml_diff>
--- a/gp_submission/ShasthoSathi_GP_Deck.pptx
+++ b/gp_submission/ShasthoSathi_GP_Deck.pptx
@@ -4791,6 +4791,191 @@
                             <a:srgbClr val="1E293B"/>
                           </a:solidFill>
                         </a:rPr>
+                        <a:t>Trained on-device NLP (multinomial NB): free Bangla/Banglish/English text → symptom flags. Held-out micro-F1 0.969, negation rejection 91%, 94.5 KB, ~ms, offline — NegEx-style negation suppression (Chapman 2001)</a:t>
+                      </a:r>
+                      <a:endParaRPr lang="en-US" sz="1400" dirty="0"/>
+                    </a:p>
+                  </a:txBody>
+                  <a:tcPr marL="91440" marR="91440" marT="45720" marB="45720">
+                    <a:lnL w="6350" cap="flat" cmpd="sng" algn="ctr">
+                      <a:solidFill>
+                        <a:srgbClr val="CBD5E1"/>
+                      </a:solidFill>
+                      <a:prstDash val="solid"/>
+                      <a:round/>
+                      <a:headEnd type="none" w="med" len="med"/>
+                      <a:tailEnd type="none" w="med" len="med"/>
+                    </a:lnL>
+                    <a:lnR w="6350" cap="flat" cmpd="sng" algn="ctr">
+                      <a:solidFill>
+                        <a:srgbClr val="CBD5E1"/>
+                      </a:solidFill>
+                      <a:prstDash val="solid"/>
+                      <a:round/>
+                      <a:headEnd type="none" w="med" len="med"/>
+                      <a:tailEnd type="none" w="med" len="med"/>
+                    </a:lnR>
+                    <a:lnT w="6350" cap="flat" cmpd="sng" algn="ctr">
+                      <a:solidFill>
+                        <a:srgbClr val="CBD5E1"/>
+                      </a:solidFill>
+                      <a:prstDash val="solid"/>
+                      <a:round/>
+                      <a:headEnd type="none" w="med" len="med"/>
+                      <a:tailEnd type="none" w="med" len="med"/>
+                    </a:lnT>
+                    <a:lnB w="6350" cap="flat" cmpd="sng" algn="ctr">
+                      <a:solidFill>
+                        <a:srgbClr val="CBD5E1"/>
+                      </a:solidFill>
+                      <a:prstDash val="solid"/>
+                      <a:round/>
+                      <a:headEnd type="none" w="med" len="med"/>
+                      <a:tailEnd type="none" w="med" len="med"/>
+                    </a:lnB>
+                    <a:solidFill>
+                      <a:srgbClr val="FFFFFF"/>
+                    </a:solidFill>
+                  </a:tcPr>
+                </a:tc>
+                <a:tc>
+                  <a:txBody>
+                    <a:bodyPr/>
+                    <a:lstStyle/>
+                    <a:p>
+                      <a:pPr indent="0" marL="0">
+                        <a:buNone/>
+                      </a:pPr>
+                      <a:r>
+                        <a:rPr lang="en-US" sz="1400" dirty="0">
+                          <a:solidFill>
+                            <a:srgbClr val="1E293B"/>
+                          </a:solidFill>
+                        </a:rPr>
+                        <a:t>voice/text → symptom flags</a:t>
+                      </a:r>
+                      <a:endParaRPr lang="en-US" sz="1400" dirty="0"/>
+                    </a:p>
+                  </a:txBody>
+                  <a:tcPr marL="91440" marR="91440" marT="45720" marB="45720">
+                    <a:lnL w="6350" cap="flat" cmpd="sng" algn="ctr">
+                      <a:solidFill>
+                        <a:srgbClr val="CBD5E1"/>
+                      </a:solidFill>
+                      <a:prstDash val="solid"/>
+                      <a:round/>
+                      <a:headEnd type="none" w="med" len="med"/>
+                      <a:tailEnd type="none" w="med" len="med"/>
+                    </a:lnL>
+                    <a:lnR w="6350" cap="flat" cmpd="sng" algn="ctr">
+                      <a:solidFill>
+                        <a:srgbClr val="CBD5E1"/>
+                      </a:solidFill>
+                      <a:prstDash val="solid"/>
+                      <a:round/>
+                      <a:headEnd type="none" w="med" len="med"/>
+                      <a:tailEnd type="none" w="med" len="med"/>
+                    </a:lnR>
+                    <a:lnT w="6350" cap="flat" cmpd="sng" algn="ctr">
+                      <a:solidFill>
+                        <a:srgbClr val="CBD5E1"/>
+                      </a:solidFill>
+                      <a:prstDash val="solid"/>
+                      <a:round/>
+                      <a:headEnd type="none" w="med" len="med"/>
+                      <a:tailEnd type="none" w="med" len="med"/>
+                    </a:lnT>
+                    <a:lnB w="6350" cap="flat" cmpd="sng" algn="ctr">
+                      <a:solidFill>
+                        <a:srgbClr val="CBD5E1"/>
+                      </a:solidFill>
+                      <a:prstDash val="solid"/>
+                      <a:round/>
+                      <a:headEnd type="none" w="med" len="med"/>
+                      <a:tailEnd type="none" w="med" len="med"/>
+                    </a:lnB>
+                    <a:solidFill>
+                      <a:srgbClr val="FFFFFF"/>
+                    </a:solidFill>
+                  </a:tcPr>
+                </a:tc>
+                <a:tc>
+                  <a:txBody>
+                    <a:bodyPr/>
+                    <a:lstStyle/>
+                    <a:p>
+                      <a:pPr indent="0" marL="0">
+                        <a:buNone/>
+                      </a:pPr>
+                      <a:r>
+                        <a:rPr lang="en-US" sz="1400" dirty="0">
+                          <a:solidFill>
+                            <a:srgbClr val="1E293B"/>
+                          </a:solidFill>
+                        </a:rPr>
+                        <a:t>runs where ChatGPT cannot: offline, private, free, feature-phone-adjacent</a:t>
+                      </a:r>
+                      <a:endParaRPr lang="en-US" sz="1400" dirty="0"/>
+                    </a:p>
+                  </a:txBody>
+                  <a:tcPr marL="91440" marR="91440" marT="45720" marB="45720">
+                    <a:lnL w="6350" cap="flat" cmpd="sng" algn="ctr">
+                      <a:solidFill>
+                        <a:srgbClr val="CBD5E1"/>
+                      </a:solidFill>
+                      <a:prstDash val="solid"/>
+                      <a:round/>
+                      <a:headEnd type="none" w="med" len="med"/>
+                      <a:tailEnd type="none" w="med" len="med"/>
+                    </a:lnL>
+                    <a:lnR w="6350" cap="flat" cmpd="sng" algn="ctr">
+                      <a:solidFill>
+                        <a:srgbClr val="CBD5E1"/>
+                      </a:solidFill>
+                      <a:prstDash val="solid"/>
+                      <a:round/>
+                      <a:headEnd type="none" w="med" len="med"/>
+                      <a:tailEnd type="none" w="med" len="med"/>
+                    </a:lnR>
+                    <a:lnT w="6350" cap="flat" cmpd="sng" algn="ctr">
+                      <a:solidFill>
+                        <a:srgbClr val="CBD5E1"/>
+                      </a:solidFill>
+                      <a:prstDash val="solid"/>
+                      <a:round/>
+                      <a:headEnd type="none" w="med" len="med"/>
+                      <a:tailEnd type="none" w="med" len="med"/>
+                    </a:lnT>
+                    <a:lnB w="6350" cap="flat" cmpd="sng" algn="ctr">
+                      <a:solidFill>
+                        <a:srgbClr val="CBD5E1"/>
+                      </a:solidFill>
+                      <a:prstDash val="solid"/>
+                      <a:round/>
+                      <a:headEnd type="none" w="med" len="med"/>
+                      <a:tailEnd type="none" w="med" len="med"/>
+                    </a:lnB>
+                    <a:solidFill>
+                      <a:srgbClr val="FFFFFF"/>
+                    </a:solidFill>
+                  </a:tcPr>
+                </a:tc>
+              </a:tr>
+              <a:tr h="502920">
+                <a:tc>
+                  <a:txBody>
+                    <a:bodyPr/>
+                    <a:lstStyle/>
+                    <a:p>
+                      <a:pPr indent="0" marL="0">
+                        <a:buNone/>
+                      </a:pPr>
+                      <a:r>
+                        <a:rPr lang="en-US" sz="1400" dirty="0">
+                          <a:solidFill>
+                            <a:srgbClr val="1E293B"/>
+                          </a:solidFill>
+                        </a:rPr>
                         <a:t>Bangla speech recognition</a:t>
                       </a:r>
                       <a:endParaRPr lang="en-US" sz="1400" dirty="0"/>

</xml_diff>

<commit_message>
deck v4: slide 6 geometry fixed (NLP row tightened, footer moved) per judge
</commit_message>
<xml_diff>
--- a/gp_submission/ShasthoSathi_GP_Deck.pptx
+++ b/gp_submission/ShasthoSathi_GP_Deck.pptx
@@ -4579,7 +4579,7 @@
           </p:nvPr>
         </p:nvGraphicFramePr>
         <p:xfrm>
-          <a:off x="640080" y="1371600"/>
+          <a:off x="640080" y="1325880"/>
           <a:ext cx="10881360" cy="914400"/>
         </p:xfrm>
         <a:graphic>
@@ -4587,11 +4587,11 @@
             <a:tbl>
               <a:tblPr/>
               <a:tblGrid>
-                <a:gridCol w="2926080"/>
-                <a:gridCol w="3840480"/>
-                <a:gridCol w="4114800"/>
+                <a:gridCol w="4206240"/>
+                <a:gridCol w="3108960"/>
+                <a:gridCol w="3566160"/>
               </a:tblGrid>
-              <a:tr h="502920">
+              <a:tr h="457200">
                 <a:tc>
                   <a:txBody>
                     <a:bodyPr/>
@@ -4601,14 +4601,14 @@
                         <a:buNone/>
                       </a:pPr>
                       <a:r>
-                        <a:rPr lang="en-US" sz="1500" b="1" dirty="0">
+                        <a:rPr lang="en-US" sz="1400" b="1" dirty="0">
                           <a:solidFill>
                             <a:srgbClr val="FFFFFF"/>
                           </a:solidFill>
                         </a:rPr>
                         <a:t>AI component</a:t>
                       </a:r>
-                      <a:endParaRPr lang="en-US" sz="1500" dirty="0"/>
+                      <a:endParaRPr lang="en-US" sz="1400" dirty="0"/>
                     </a:p>
                   </a:txBody>
                   <a:tcPr marL="91440" marR="91440" marT="45720" marB="45720">
@@ -4662,14 +4662,14 @@
                         <a:buNone/>
                       </a:pPr>
                       <a:r>
-                        <a:rPr lang="en-US" sz="1500" b="1" dirty="0">
+                        <a:rPr lang="en-US" sz="1400" b="1" dirty="0">
                           <a:solidFill>
                             <a:srgbClr val="FFFFFF"/>
                           </a:solidFill>
                         </a:rPr>
                         <a:t>Input → Output</a:t>
                       </a:r>
-                      <a:endParaRPr lang="en-US" sz="1500" dirty="0"/>
+                      <a:endParaRPr lang="en-US" sz="1400" dirty="0"/>
                     </a:p>
                   </a:txBody>
                   <a:tcPr marL="91440" marR="91440" marT="45720" marB="45720">
@@ -4723,14 +4723,14 @@
                         <a:buNone/>
                       </a:pPr>
                       <a:r>
-                        <a:rPr lang="en-US" sz="1500" b="1" dirty="0">
+                        <a:rPr lang="en-US" sz="1400" b="1" dirty="0">
                           <a:solidFill>
                             <a:srgbClr val="FFFFFF"/>
                           </a:solidFill>
                         </a:rPr>
                         <a:t>Why AI / guardrail</a:t>
                       </a:r>
-                      <a:endParaRPr lang="en-US" sz="1500" dirty="0"/>
+                      <a:endParaRPr lang="en-US" sz="1400" dirty="0"/>
                     </a:p>
                   </a:txBody>
                   <a:tcPr marL="91440" marR="91440" marT="45720" marB="45720">
@@ -4776,7 +4776,7 @@
                   </a:tcPr>
                 </a:tc>
               </a:tr>
-              <a:tr h="502920">
+              <a:tr h="457200">
                 <a:tc>
                   <a:txBody>
                     <a:bodyPr/>
@@ -4786,14 +4786,14 @@
                         <a:buNone/>
                       </a:pPr>
                       <a:r>
-                        <a:rPr lang="en-US" sz="1400" dirty="0">
+                        <a:rPr lang="en-US" sz="1250" dirty="0">
                           <a:solidFill>
                             <a:srgbClr val="1E293B"/>
                           </a:solidFill>
                         </a:rPr>
-                        <a:t>Trained on-device NLP (multinomial NB): free Bangla/Banglish/English text → symptom flags. Held-out micro-F1 0.969, negation rejection 91%, 94.5 KB, ~ms, offline — NegEx-style negation suppression (Chapman 2001)</a:t>
+                        <a:t>Trained on-device NLP (multinomial NB): free Bangla/Banglish/English → symptom flags. Held-out micro-F1 0.969, negation rejection 91% (NegEx, Chapman 2001). 94.5 KB, ~ms, fully offline</a:t>
                       </a:r>
-                      <a:endParaRPr lang="en-US" sz="1400" dirty="0"/>
+                      <a:endParaRPr lang="en-US" sz="1250" dirty="0"/>
                     </a:p>
                   </a:txBody>
                   <a:tcPr marL="91440" marR="91440" marT="45720" marB="45720">
@@ -4847,14 +4847,14 @@
                         <a:buNone/>
                       </a:pPr>
                       <a:r>
-                        <a:rPr lang="en-US" sz="1400" dirty="0">
+                        <a:rPr lang="en-US" sz="1250" dirty="0">
                           <a:solidFill>
                             <a:srgbClr val="1E293B"/>
                           </a:solidFill>
                         </a:rPr>
-                        <a:t>voice/text → symptom flags</a:t>
+                        <a:t>voice/text → flags</a:t>
                       </a:r>
-                      <a:endParaRPr lang="en-US" sz="1400" dirty="0"/>
+                      <a:endParaRPr lang="en-US" sz="1250" dirty="0"/>
                     </a:p>
                   </a:txBody>
                   <a:tcPr marL="91440" marR="91440" marT="45720" marB="45720">
@@ -4908,14 +4908,14 @@
                         <a:buNone/>
                       </a:pPr>
                       <a:r>
-                        <a:rPr lang="en-US" sz="1400" dirty="0">
+                        <a:rPr lang="en-US" sz="1250" dirty="0">
                           <a:solidFill>
                             <a:srgbClr val="1E293B"/>
                           </a:solidFill>
                         </a:rPr>
-                        <a:t>runs where ChatGPT cannot: offline, private, free, feature-phone-adjacent</a:t>
+                        <a:t>works where ChatGPT cannot: offline, private, free</a:t>
                       </a:r>
-                      <a:endParaRPr lang="en-US" sz="1400" dirty="0"/>
+                      <a:endParaRPr lang="en-US" sz="1250" dirty="0"/>
                     </a:p>
                   </a:txBody>
                   <a:tcPr marL="91440" marR="91440" marT="45720" marB="45720">
@@ -4961,7 +4961,7 @@
                   </a:tcPr>
                 </a:tc>
               </a:tr>
-              <a:tr h="502920">
+              <a:tr h="457200">
                 <a:tc>
                   <a:txBody>
                     <a:bodyPr/>
@@ -4971,14 +4971,14 @@
                         <a:buNone/>
                       </a:pPr>
                       <a:r>
-                        <a:rPr lang="en-US" sz="1400" dirty="0">
+                        <a:rPr lang="en-US" sz="1250" dirty="0">
                           <a:solidFill>
                             <a:srgbClr val="1E293B"/>
                           </a:solidFill>
                         </a:rPr>
                         <a:t>Bangla speech recognition</a:t>
                       </a:r>
-                      <a:endParaRPr lang="en-US" sz="1400" dirty="0"/>
+                      <a:endParaRPr lang="en-US" sz="1250" dirty="0"/>
                     </a:p>
                   </a:txBody>
                   <a:tcPr marL="91440" marR="91440" marT="45720" marB="45720">
@@ -5032,14 +5032,14 @@
                         <a:buNone/>
                       </a:pPr>
                       <a:r>
-                        <a:rPr lang="en-US" sz="1400" dirty="0">
+                        <a:rPr lang="en-US" sz="1250" dirty="0">
                           <a:solidFill>
                             <a:srgbClr val="1E293B"/>
                           </a:solidFill>
                         </a:rPr>
                         <a:t>voice → symptom list</a:t>
                       </a:r>
-                      <a:endParaRPr lang="en-US" sz="1400" dirty="0"/>
+                      <a:endParaRPr lang="en-US" sz="1250" dirty="0"/>
                     </a:p>
                   </a:txBody>
                   <a:tcPr marL="91440" marR="91440" marT="45720" marB="45720">
@@ -5093,14 +5093,14 @@
                         <a:buNone/>
                       </a:pPr>
                       <a:r>
-                        <a:rPr lang="en-US" sz="1400" dirty="0">
+                        <a:rPr lang="en-US" sz="1250" dirty="0">
                           <a:solidFill>
                             <a:srgbClr val="1E293B"/>
                           </a:solidFill>
                         </a:rPr>
                         <a:t>removes literacy barrier</a:t>
                       </a:r>
-                      <a:endParaRPr lang="en-US" sz="1400" dirty="0"/>
+                      <a:endParaRPr lang="en-US" sz="1250" dirty="0"/>
                     </a:p>
                   </a:txBody>
                   <a:tcPr marL="91440" marR="91440" marT="45720" marB="45720">
@@ -5146,7 +5146,7 @@
                   </a:tcPr>
                 </a:tc>
               </a:tr>
-              <a:tr h="502920">
+              <a:tr h="457200">
                 <a:tc>
                   <a:txBody>
                     <a:bodyPr/>
@@ -5156,14 +5156,14 @@
                         <a:buNone/>
                       </a:pPr>
                       <a:r>
-                        <a:rPr lang="en-US" sz="1400" dirty="0">
+                        <a:rPr lang="en-US" sz="1250" dirty="0">
                           <a:solidFill>
                             <a:srgbClr val="1E293B"/>
                           </a:solidFill>
                         </a:rPr>
                         <a:t>Explainable triage engine</a:t>
                       </a:r>
-                      <a:endParaRPr lang="en-US" sz="1400" dirty="0"/>
+                      <a:endParaRPr lang="en-US" sz="1250" dirty="0"/>
                     </a:p>
                   </a:txBody>
                   <a:tcPr marL="91440" marR="91440" marT="45720" marB="45720">
@@ -5217,14 +5217,14 @@
                         <a:buNone/>
                       </a:pPr>
                       <a:r>
-                        <a:rPr lang="en-US" sz="1400" dirty="0">
+                        <a:rPr lang="en-US" sz="1250" dirty="0">
                           <a:solidFill>
                             <a:srgbClr val="1E293B"/>
                           </a:solidFill>
                         </a:rPr>
                         <a:t>flags → care level + reasons</a:t>
                       </a:r>
-                      <a:endParaRPr lang="en-US" sz="1400" dirty="0"/>
+                      <a:endParaRPr lang="en-US" sz="1250" dirty="0"/>
                     </a:p>
                   </a:txBody>
                   <a:tcPr marL="91440" marR="91440" marT="45720" marB="45720">
@@ -5278,14 +5278,14 @@
                         <a:buNone/>
                       </a:pPr>
                       <a:r>
-                        <a:rPr lang="en-US" sz="1400" dirty="0">
+                        <a:rPr lang="en-US" sz="1250" dirty="0">
                           <a:solidFill>
                             <a:srgbClr val="1E293B"/>
                           </a:solidFill>
                         </a:rPr>
                         <a:t>WHO rules as auditable code — not a black box</a:t>
                       </a:r>
-                      <a:endParaRPr lang="en-US" sz="1400" dirty="0"/>
+                      <a:endParaRPr lang="en-US" sz="1250" dirty="0"/>
                     </a:p>
                   </a:txBody>
                   <a:tcPr marL="91440" marR="91440" marT="45720" marB="45720">
@@ -5331,7 +5331,7 @@
                   </a:tcPr>
                 </a:tc>
               </a:tr>
-              <a:tr h="502920">
+              <a:tr h="457200">
                 <a:tc>
                   <a:txBody>
                     <a:bodyPr/>
@@ -5341,14 +5341,14 @@
                         <a:buNone/>
                       </a:pPr>
                       <a:r>
-                        <a:rPr lang="en-US" sz="1400" dirty="0">
+                        <a:rPr lang="en-US" sz="1250" dirty="0">
                           <a:solidFill>
                             <a:srgbClr val="1E293B"/>
                           </a:solidFill>
                         </a:rPr>
                         <a:t>SMS NLP</a:t>
                       </a:r>
-                      <a:endParaRPr lang="en-US" sz="1400" dirty="0"/>
+                      <a:endParaRPr lang="en-US" sz="1250" dirty="0"/>
                     </a:p>
                   </a:txBody>
                   <a:tcPr marL="91440" marR="91440" marT="45720" marB="45720">
@@ -5402,14 +5402,14 @@
                         <a:buNone/>
                       </a:pPr>
                       <a:r>
-                        <a:rPr lang="en-US" sz="1400" dirty="0">
+                        <a:rPr lang="en-US" sz="1250" dirty="0">
                           <a:solidFill>
                             <a:srgbClr val="1E293B"/>
                           </a:solidFill>
                         </a:rPr>
                         <a:t>coded text → same triage</a:t>
                       </a:r>
-                      <a:endParaRPr lang="en-US" sz="1400" dirty="0"/>
+                      <a:endParaRPr lang="en-US" sz="1250" dirty="0"/>
                     </a:p>
                   </a:txBody>
                   <a:tcPr marL="91440" marR="91440" marT="45720" marB="45720">
@@ -5463,14 +5463,14 @@
                         <a:buNone/>
                       </a:pPr>
                       <a:r>
-                        <a:rPr lang="en-US" sz="1400" dirty="0">
+                        <a:rPr lang="en-US" sz="1250" dirty="0">
                           <a:solidFill>
                             <a:srgbClr val="1E293B"/>
                           </a:solidFill>
                         </a:rPr>
                         <a:t>reaches feature phones</a:t>
                       </a:r>
-                      <a:endParaRPr lang="en-US" sz="1400" dirty="0"/>
+                      <a:endParaRPr lang="en-US" sz="1250" dirty="0"/>
                     </a:p>
                   </a:txBody>
                   <a:tcPr marL="91440" marR="91440" marT="45720" marB="45720">
@@ -5516,7 +5516,7 @@
                   </a:tcPr>
                 </a:tc>
               </a:tr>
-              <a:tr h="502920">
+              <a:tr h="457200">
                 <a:tc>
                   <a:txBody>
                     <a:bodyPr/>
@@ -5526,14 +5526,14 @@
                         <a:buNone/>
                       </a:pPr>
                       <a:r>
-                        <a:rPr lang="en-US" sz="1400" dirty="0">
+                        <a:rPr lang="en-US" sz="1250" dirty="0">
                           <a:solidFill>
                             <a:srgbClr val="1E293B"/>
                           </a:solidFill>
                         </a:rPr>
                         <a:t>Climate-lag ML model</a:t>
                       </a:r>
-                      <a:endParaRPr lang="en-US" sz="1400" dirty="0"/>
+                      <a:endParaRPr lang="en-US" sz="1250" dirty="0"/>
                     </a:p>
                   </a:txBody>
                   <a:tcPr marL="91440" marR="91440" marT="45720" marB="45720">
@@ -5587,14 +5587,14 @@
                         <a:buNone/>
                       </a:pPr>
                       <a:r>
-                        <a:rPr lang="en-US" sz="1400" dirty="0">
+                        <a:rPr lang="en-US" sz="1250" dirty="0">
                           <a:solidFill>
                             <a:srgbClr val="1E293B"/>
                           </a:solidFill>
                         </a:rPr>
                         <a:t>rain/humidity → risk index</a:t>
                       </a:r>
-                      <a:endParaRPr lang="en-US" sz="1400" dirty="0"/>
+                      <a:endParaRPr lang="en-US" sz="1250" dirty="0"/>
                     </a:p>
                   </a:txBody>
                   <a:tcPr marL="91440" marR="91440" marT="45720" marB="45720">
@@ -5648,14 +5648,14 @@
                         <a:buNone/>
                       </a:pPr>
                       <a:r>
-                        <a:rPr lang="en-US" sz="1400" dirty="0">
+                        <a:rPr lang="en-US" sz="1250" dirty="0">
                           <a:solidFill>
                             <a:srgbClr val="1E293B"/>
                           </a:solidFill>
                         </a:rPr>
                         <a:t>weather leads cases by weeks; limits disclosed</a:t>
                       </a:r>
-                      <a:endParaRPr lang="en-US" sz="1400" dirty="0"/>
+                      <a:endParaRPr lang="en-US" sz="1250" dirty="0"/>
                     </a:p>
                   </a:txBody>
                   <a:tcPr marL="91440" marR="91440" marT="45720" marB="45720">
@@ -5701,7 +5701,7 @@
                   </a:tcPr>
                 </a:tc>
               </a:tr>
-              <a:tr h="502920">
+              <a:tr h="457200">
                 <a:tc>
                   <a:txBody>
                     <a:bodyPr/>
@@ -5711,14 +5711,14 @@
                         <a:buNone/>
                       </a:pPr>
                       <a:r>
-                        <a:rPr lang="en-US" sz="1400" dirty="0">
+                        <a:rPr lang="en-US" sz="1250" dirty="0">
                           <a:solidFill>
                             <a:srgbClr val="1E293B"/>
                           </a:solidFill>
                         </a:rPr>
                         <a:t>On-device OCR + TTS</a:t>
                       </a:r>
-                      <a:endParaRPr lang="en-US" sz="1400" dirty="0"/>
+                      <a:endParaRPr lang="en-US" sz="1250" dirty="0"/>
                     </a:p>
                   </a:txBody>
                   <a:tcPr marL="91440" marR="91440" marT="45720" marB="45720">
@@ -5772,14 +5772,14 @@
                         <a:buNone/>
                       </a:pPr>
                       <a:r>
-                        <a:rPr lang="en-US" sz="1400" dirty="0">
+                        <a:rPr lang="en-US" sz="1250" dirty="0">
                           <a:solidFill>
                             <a:srgbClr val="1E293B"/>
                           </a:solidFill>
                         </a:rPr>
                         <a:t>medicine photo → read-aloud</a:t>
                       </a:r>
-                      <a:endParaRPr lang="en-US" sz="1400" dirty="0"/>
+                      <a:endParaRPr lang="en-US" sz="1250" dirty="0"/>
                     </a:p>
                   </a:txBody>
                   <a:tcPr marL="91440" marR="91440" marT="45720" marB="45720">
@@ -5833,14 +5833,14 @@
                         <a:buNone/>
                       </a:pPr>
                       <a:r>
-                        <a:rPr lang="en-US" sz="1400" dirty="0">
+                        <a:rPr lang="en-US" sz="1250" dirty="0">
                           <a:solidFill>
                             <a:srgbClr val="1E293B"/>
                           </a:solidFill>
                         </a:rPr>
                         <a:t>independent use by low-literacy patients</a:t>
                       </a:r>
-                      <a:endParaRPr lang="en-US" sz="1400" dirty="0"/>
+                      <a:endParaRPr lang="en-US" sz="1250" dirty="0"/>
                     </a:p>
                   </a:txBody>
                   <a:tcPr marL="91440" marR="91440" marT="45720" marB="45720">
@@ -5898,8 +5898,8 @@
         </p:nvSpPr>
         <p:spPr>
           <a:xfrm>
-            <a:off x="640080" y="5120640"/>
-            <a:ext cx="10881360" cy="731520"/>
+            <a:off x="640080" y="5897880"/>
+            <a:ext cx="10881360" cy="502920"/>
           </a:xfrm>
           <a:prstGeom prst="rect">
             <a:avLst/>
@@ -5915,14 +5915,14 @@
               <a:buNone/>
             </a:pPr>
             <a:r>
-              <a:rPr lang="en-US" sz="1500" i="1" dirty="0">
+              <a:rPr lang="en-US" sz="1300" i="1" dirty="0">
                 <a:solidFill>
                   <a:srgbClr val="134E4A"/>
                 </a:solidFill>
               </a:rPr>
               <a:t>Responsible-AI position: AI is decision SUPPORT — every screen says “not a doctor” · personal data stays on-device · model limits published in-app (Model Card).</a:t>
             </a:r>
-            <a:endParaRPr lang="en-US" sz="1500" dirty="0"/>
+            <a:endParaRPr lang="en-US" sz="1300" dirty="0"/>
           </a:p>
         </p:txBody>
       </p:sp>

</xml_diff>